<commit_message>
feat: integrar CaaS y defensa ante DDoS
</commit_message>
<xml_diff>
--- a/classes/parte-1-redes-y-seguridad-de-redes/045-netflow-y-analisis-de-metadatos-de-trafico/clase-045-presentacion.pptx
+++ b/classes/parte-1-redes-y-seguridad-de-redes/045-netflow-y-analisis-de-metadatos-de-trafico/clase-045-presentacion.pptx
@@ -3269,7 +3269,7 @@
                   <a:srgbClr val="22282E"/>
                 </a:solidFill>
               </a:rPr>
-              <a:t>•  Explica cómo se vería un ataque DDoS volumétrico en los metadatos de flujo.</a:t>
+              <a:t>•  Explica cómo se vería un posible DDoS volumétrico y qué descartaría un pico legítimo.</a:t>
             </a:r>
           </a:p>
           <a:p>
@@ -3881,6 +3881,36 @@
                 </a:solidFill>
               </a:rPr>
               <a:t>•  CERT NetSA — SiLK. &lt;https://tools.netsa.cert.org/silk/&gt;</a:t>
+            </a:r>
+          </a:p>
+          <a:p>
+            <a:pPr>
+              <a:spcAft>
+                <a:spcPts val="600"/>
+              </a:spcAft>
+            </a:pPr>
+            <a:r>
+              <a:rPr sz="1500">
+                <a:solidFill>
+                  <a:srgbClr val="22282E"/>
+                </a:solidFill>
+              </a:rPr>
+              <a:t>•  MITRE ATT&amp;CK — Network Denial of Service (T1498). &lt;https://attack.mitre.org/techniques/T1498/&gt;</a:t>
+            </a:r>
+          </a:p>
+          <a:p>
+            <a:pPr>
+              <a:spcAft>
+                <a:spcPts val="600"/>
+              </a:spcAft>
+            </a:pPr>
+            <a:r>
+              <a:rPr sz="1500">
+                <a:solidFill>
+                  <a:srgbClr val="22282E"/>
+                </a:solidFill>
+              </a:rPr>
+              <a:t>•  CISA — Volumetric DDoS Technical Guidance. &lt;https://www.cisa.gov/sites/default/files/2023-09/TLP%20CLEAR%20-DDOS%20Mitigations%20Guidance508c.pdf&gt;</a:t>
             </a:r>
           </a:p>
         </p:txBody>

</xml_diff>